<commit_message>
Improve pitch deck visuals with better alignment and contrast
Update pitch deck presentation with proportionally aligned 16:9 screenshots and added gold borders for improved contrast.

Replit-Commit-Author: Agent
Replit-Commit-Session-Id: 85f09f3c-352d-446d-b98e-3f307c26fc5a
Replit-Commit-Checkpoint-Type: full_checkpoint
Replit-Commit-Event-Id: 9ed37251-20ab-4705-8b75-601d34734207
Replit-Commit-Screenshot-Url: https://storage.googleapis.com/screenshot-production-us-central1/3bd53afc-ff4f-401b-9e3d-b367791ef629/85f09f3c-352d-446d-b98e-3f307c26fc5a/MPe9Toz
Replit-Helium-Checkpoint-Created: true
</commit_message>
<xml_diff>
--- a/attached_assets/VaughnMartin_Pitch_Deck_UPDATED_2026.pptx
+++ b/attached_assets/VaughnMartin_Pitch_Deck_UPDATED_2026.pptx
@@ -2661,7 +2661,7 @@
       </p:sp>
       <p:pic>
         <p:nvPicPr>
-          <p:cNvPr id="37" name="Picture 36" descr="s1_problem.jpg"/>
+          <p:cNvPr id="37" name="Picture 36" descr="s1.jpg"/>
           <p:cNvPicPr>
             <a:picLocks noChangeAspect="1"/>
           </p:cNvPicPr>
@@ -2675,8 +2675,8 @@
         </p:blipFill>
         <p:spPr>
           <a:xfrm>
-            <a:off x="4215384" y="402336"/>
-            <a:ext cx="4782312" cy="4636008"/>
+            <a:off x="4160520" y="1197864"/>
+            <a:ext cx="4846320" cy="2724912"/>
           </a:xfrm>
           <a:prstGeom prst="rect">
             <a:avLst/>
@@ -4975,7 +4975,7 @@
                 <a:ea typeface="Calibri" pitchFamily="34" charset="-122"/>
                 <a:cs typeface="Calibri" pitchFamily="34" charset="-120"/>
               </a:rPr>
-              <a:t>▶  MONITOR  248+ data points. 16 signal categories checked every 15 minutes. System surfaces signals before they go public — detected on your terms.</a:t>
+              <a:t>▶  MONITOR  248+ data points. 16 signal categories checked every 15 minutes. System surfaces signals before they go public — on your terms.</a:t>
             </a:r>
             <a:pPr indent="0" marL="0">
               <a:lnSpc>
@@ -5602,7 +5602,7 @@
       </p:sp>
       <p:pic>
         <p:nvPicPr>
-          <p:cNvPr id="35" name="Picture 34" descr="s3_product.jpg"/>
+          <p:cNvPr id="35" name="Picture 34" descr="s3.jpg"/>
           <p:cNvPicPr>
             <a:picLocks noChangeAspect="1"/>
           </p:cNvPicPr>
@@ -5616,8 +5616,8 @@
         </p:blipFill>
         <p:spPr>
           <a:xfrm>
-            <a:off x="4215384" y="402336"/>
-            <a:ext cx="4782312" cy="4636008"/>
+            <a:off x="4160520" y="1197864"/>
+            <a:ext cx="4846320" cy="2724912"/>
           </a:xfrm>
           <a:prstGeom prst="rect">
             <a:avLst/>
@@ -8629,7 +8629,7 @@
       </p:sp>
       <p:pic>
         <p:nvPicPr>
-          <p:cNvPr id="36" name="Picture 35" descr="s5_how.jpg"/>
+          <p:cNvPr id="36" name="Picture 35" descr="s5.jpg"/>
           <p:cNvPicPr>
             <a:picLocks noChangeAspect="1"/>
           </p:cNvPicPr>
@@ -8643,8 +8643,8 @@
         </p:blipFill>
         <p:spPr>
           <a:xfrm>
-            <a:off x="4215384" y="402336"/>
-            <a:ext cx="4782312" cy="4636008"/>
+            <a:off x="4160520" y="1197864"/>
+            <a:ext cx="4846320" cy="2724912"/>
           </a:xfrm>
           <a:prstGeom prst="rect">
             <a:avLst/>
@@ -9714,7 +9714,7 @@
       </p:sp>
       <p:pic>
         <p:nvPicPr>
-          <p:cNvPr id="36" name="Picture 35" descr="s6_proof.jpg"/>
+          <p:cNvPr id="36" name="Picture 35" descr="s6.jpg"/>
           <p:cNvPicPr>
             <a:picLocks noChangeAspect="1"/>
           </p:cNvPicPr>
@@ -9728,8 +9728,8 @@
         </p:blipFill>
         <p:spPr>
           <a:xfrm>
-            <a:off x="4215384" y="402336"/>
-            <a:ext cx="4782312" cy="4636008"/>
+            <a:off x="4160520" y="1197864"/>
+            <a:ext cx="4846320" cy="2724912"/>
           </a:xfrm>
           <a:prstGeom prst="rect">
             <a:avLst/>
@@ -10765,7 +10765,7 @@
       </p:sp>
       <p:pic>
         <p:nvPicPr>
-          <p:cNvPr id="36" name="Picture 35" descr="s7_roi.jpg"/>
+          <p:cNvPr id="36" name="Picture 35" descr="s7.jpg"/>
           <p:cNvPicPr>
             <a:picLocks noChangeAspect="1"/>
           </p:cNvPicPr>
@@ -10779,8 +10779,8 @@
         </p:blipFill>
         <p:spPr>
           <a:xfrm>
-            <a:off x="4215384" y="402336"/>
-            <a:ext cx="4782312" cy="4636008"/>
+            <a:off x="4160520" y="1197864"/>
+            <a:ext cx="4846320" cy="2724912"/>
           </a:xfrm>
           <a:prstGeom prst="rect">
             <a:avLst/>
@@ -12028,7 +12028,7 @@
       </p:sp>
       <p:pic>
         <p:nvPicPr>
-          <p:cNvPr id="38" name="Picture 37" descr="s8_close.jpg"/>
+          <p:cNvPr id="38" name="Picture 37" descr="s8.jpg"/>
           <p:cNvPicPr>
             <a:picLocks noChangeAspect="1"/>
           </p:cNvPicPr>
@@ -12042,8 +12042,8 @@
         </p:blipFill>
         <p:spPr>
           <a:xfrm>
-            <a:off x="4215384" y="402336"/>
-            <a:ext cx="4782312" cy="4636008"/>
+            <a:off x="4160520" y="1197864"/>
+            <a:ext cx="4846320" cy="2724912"/>
           </a:xfrm>
           <a:prstGeom prst="rect">
             <a:avLst/>

</xml_diff>